<commit_message>
Slide 1: align column headers with icons, align follow-up cell padding
Co-Authored-By: Claude Opus 5.5 <noreply@anthropic.com>
Claude-Session: https://claude.ai/code/session_01QGTe9h3kfUS6BTZosfrxzF
</commit_message>
<xml_diff>
--- a/resumen-ejecutivo-semanal/presentacion_depto_riesgos.pptx
+++ b/resumen-ejecutivo-semanal/presentacion_depto_riesgos.pptx
@@ -973,8 +973,8 @@
         </p:nvSpPr>
         <p:spPr>
           <a:xfrm>
-            <a:off x="4611625" y="1193292"/>
-            <a:ext cx="1344328" cy="310896"/>
+            <a:off x="3419856" y="1207008"/>
+            <a:ext cx="4151376" cy="310896"/>
           </a:xfrm>
           <a:prstGeom prst="rect">
             <a:avLst/>
@@ -990,7 +990,7 @@
               <a:buNone/>
             </a:pPr>
             <a:r>
-              <a:rPr lang="en-US" sz="1200" b="1" dirty="0">
+              <a:rPr lang="en-US" sz="1300" b="1" dirty="0">
                 <a:solidFill>
                   <a:srgbClr val="FFFFFF"/>
                 </a:solidFill>
@@ -1004,6 +1004,30 @@
           </a:p>
         </p:txBody>
       </p:sp>
+      <p:pic>
+        <p:nvPicPr>
+          <p:cNvPr id="60" name="Icono Text 3"/>
+          <p:cNvPicPr>
+            <a:picLocks noChangeAspect="1"/>
+          </p:cNvPicPr>
+          <p:nvPr/>
+        </p:nvPicPr>
+        <p:blipFill>
+          <a:blip r:embed="rId7"/>
+          <a:stretch>
+            <a:fillRect/>
+          </a:stretch>
+        </p:blipFill>
+        <p:spPr>
+          <a:xfrm>
+            <a:off x="4636007" y="1271016"/>
+            <a:ext cx="182880" cy="182880"/>
+          </a:xfrm>
+          <a:prstGeom prst="rect">
+            <a:avLst/>
+          </a:prstGeom>
+        </p:spPr>
+      </p:pic>
       <p:sp>
         <p:nvSpPr>
           <p:cNvPr id="6" name="Shape 4"/>
@@ -1052,8 +1076,8 @@
         </p:nvSpPr>
         <p:spPr>
           <a:xfrm>
-            <a:off x="8741423" y="1203238"/>
-            <a:ext cx="1865857" cy="310896"/>
+            <a:off x="7708392" y="1207008"/>
+            <a:ext cx="4151376" cy="310896"/>
           </a:xfrm>
           <a:prstGeom prst="rect">
             <a:avLst/>
@@ -1069,7 +1093,7 @@
               <a:buNone/>
             </a:pPr>
             <a:r>
-              <a:rPr lang="en-US" sz="1200" b="1" dirty="0">
+              <a:rPr lang="en-US" sz="1300" b="1" dirty="0">
                 <a:solidFill>
                   <a:srgbClr val="FFFFFF"/>
                 </a:solidFill>
@@ -1083,6 +1107,30 @@
           </a:p>
         </p:txBody>
       </p:sp>
+      <p:pic>
+        <p:nvPicPr>
+          <p:cNvPr id="61" name="Icono Text 5"/>
+          <p:cNvPicPr>
+            <a:picLocks noChangeAspect="1"/>
+          </p:cNvPicPr>
+          <p:nvPr/>
+        </p:nvPicPr>
+        <p:blipFill>
+          <a:blip r:embed="rId8"/>
+          <a:stretch>
+            <a:fillRect/>
+          </a:stretch>
+        </p:blipFill>
+        <p:spPr>
+          <a:xfrm>
+            <a:off x="8558784" y="1271016"/>
+            <a:ext cx="182880" cy="182880"/>
+          </a:xfrm>
+          <a:prstGeom prst="rect">
+            <a:avLst/>
+          </a:prstGeom>
+        </p:spPr>
+      </p:pic>
       <p:sp>
         <p:nvSpPr>
           <p:cNvPr id="8" name="Shape 6"/>
@@ -1310,8 +1358,8 @@
         </p:nvSpPr>
         <p:spPr>
           <a:xfrm>
-            <a:off x="3319272" y="1773936"/>
-            <a:ext cx="4133088" cy="1225296"/>
+            <a:off x="3456432" y="1773936"/>
+            <a:ext cx="3913632" cy="1225296"/>
           </a:xfrm>
           <a:prstGeom prst="rect">
             <a:avLst/>

</xml_diff>